<commit_message>
updated to 5000+ dataset and fixed type conversion
</commit_message>
<xml_diff>
--- a/FinSeva_Project_Presentation.pptx
+++ b/FinSeva_Project_Presentation.pptx
@@ -5,7 +5,7 @@
     <p:sldMasterId id="2147483648" r:id="rId1"/>
   </p:sldMasterIdLst>
   <p:notesMasterIdLst>
-    <p:notesMasterId r:id="rId9"/>
+    <p:notesMasterId r:id="rId10"/>
   </p:notesMasterIdLst>
   <p:sldIdLst>
     <p:sldId id="256" r:id="rId2"/>
@@ -14,7 +14,8 @@
     <p:sldId id="259" r:id="rId5"/>
     <p:sldId id="260" r:id="rId6"/>
     <p:sldId id="261" r:id="rId7"/>
-    <p:sldId id="263" r:id="rId8"/>
+    <p:sldId id="262" r:id="rId8"/>
+    <p:sldId id="263" r:id="rId9"/>
   </p:sldIdLst>
   <p:sldSz cx="12192000" cy="6858000"/>
   <p:notesSz cx="6858000" cy="12192000"/>
@@ -143,7 +144,7 @@
     </p:spTree>
     <p:extLst>
       <p:ext uri="{BB962C8B-B14F-4D97-AF65-F5344CB8AC3E}">
-        <p14:creationId xmlns:p14="http://schemas.microsoft.com/office/powerpoint/2010/main" val="2629885860"/>
+        <p14:creationId xmlns:p14="http://schemas.microsoft.com/office/powerpoint/2010/main" val="1947817044"/>
       </p:ext>
     </p:extLst>
   </p:cSld>
@@ -831,6 +832,90 @@
 </p:notes>
 </file>
 
+<file path=ppt/notesSlides/notesSlide8.xml><?xml version="1.0" encoding="utf-8"?>
+<p:notes xmlns:a="http://schemas.openxmlformats.org/drawingml/2006/main" xmlns:r="http://schemas.openxmlformats.org/officeDocument/2006/relationships" xmlns:p="http://schemas.openxmlformats.org/presentationml/2006/main">
+  <p:cSld>
+    <p:spTree>
+      <p:nvGrpSpPr>
+        <p:cNvPr id="1" name=""/>
+        <p:cNvGrpSpPr/>
+        <p:nvPr/>
+      </p:nvGrpSpPr>
+      <p:grpSpPr>
+        <a:xfrm>
+          <a:off x="0" y="0"/>
+          <a:ext cx="0" cy="0"/>
+          <a:chOff x="0" y="0"/>
+          <a:chExt cx="0" cy="0"/>
+        </a:xfrm>
+      </p:grpSpPr>
+      <p:sp>
+        <p:nvSpPr>
+          <p:cNvPr id="2" name="Slide Image Placeholder 1"/>
+          <p:cNvSpPr>
+            <a:spLocks noGrp="1" noRot="1" noChangeAspect="1"/>
+          </p:cNvSpPr>
+          <p:nvPr>
+            <p:ph type="sldImg"/>
+          </p:nvPr>
+        </p:nvSpPr>
+        <p:spPr/>
+      </p:sp>
+      <p:sp>
+        <p:nvSpPr>
+          <p:cNvPr id="3" name="Notes Placeholder 2"/>
+          <p:cNvSpPr>
+            <a:spLocks noGrp="1"/>
+          </p:cNvSpPr>
+          <p:nvPr>
+            <p:ph type="body" idx="1"/>
+          </p:nvPr>
+        </p:nvSpPr>
+        <p:spPr/>
+        <p:txBody>
+          <a:bodyPr/>
+          <a:lstStyle/>
+          <a:p>
+            <a:endParaRPr lang="en-US" dirty="0"/>
+          </a:p>
+        </p:txBody>
+      </p:sp>
+      <p:sp>
+        <p:nvSpPr>
+          <p:cNvPr id="4" name="Slide Number Placeholder 3"/>
+          <p:cNvSpPr>
+            <a:spLocks noGrp="1"/>
+          </p:cNvSpPr>
+          <p:nvPr>
+            <p:ph type="sldNum" sz="quarter" idx="10"/>
+          </p:nvPr>
+        </p:nvSpPr>
+        <p:spPr/>
+        <p:txBody>
+          <a:bodyPr/>
+          <a:lstStyle/>
+          <a:p>
+            <a:fld id="{F7021451-1387-4CA6-816F-3879F97B5CBC}" type="slidenum">
+              <a:rPr lang="en-US"/>
+              <a:t>8</a:t>
+            </a:fld>
+            <a:endParaRPr lang="en-US"/>
+          </a:p>
+        </p:txBody>
+      </p:sp>
+    </p:spTree>
+    <p:extLst>
+      <p:ext uri="{BB962C8B-B14F-4D97-AF65-F5344CB8AC3E}">
+        <p14:creationId xmlns:p14="http://schemas.microsoft.com/office/powerpoint/2010/main" val="1024086991"/>
+      </p:ext>
+    </p:extLst>
+  </p:cSld>
+  <p:clrMapOvr>
+    <a:masterClrMapping/>
+  </p:clrMapOvr>
+</p:notes>
+</file>
+
 <file path=ppt/slideLayouts/slideLayout1.xml><?xml version="1.0" encoding="utf-8"?>
 <p:sldLayout xmlns:a="http://schemas.openxmlformats.org/drawingml/2006/main" xmlns:r="http://schemas.openxmlformats.org/officeDocument/2006/relationships" xmlns:p="http://schemas.openxmlformats.org/presentationml/2006/main" preserve="1">
   <p:cSld name="DEFAULT">
@@ -1197,13 +1282,14 @@
                 <a:solidFill>
                   <a:srgbClr val="FFFFFF"/>
                 </a:solidFill>
-                <a:latin typeface="Calibri" pitchFamily="34" charset="0"/>
-                <a:ea typeface="Calibri" pitchFamily="34" charset="-122"/>
-                <a:cs typeface="Calibri" pitchFamily="34" charset="-120"/>
+                <a:ea typeface="Calibri" pitchFamily="34" charset="-122"/>
+                <a:cs typeface="Arial" panose="020B0604020202020204" pitchFamily="34" charset="0"/>
               </a:rPr>
               <a:t>FinSeva Solutions Pvt. Ltd.</a:t>
             </a:r>
-            <a:endParaRPr lang="en-US" sz="4400" dirty="0"/>
+            <a:endParaRPr lang="en-US" sz="4400" dirty="0">
+              <a:cs typeface="Arial" panose="020B0604020202020204" pitchFamily="34" charset="0"/>
+            </a:endParaRPr>
           </a:p>
         </p:txBody>
       </p:sp>
@@ -1236,25 +1322,26 @@
                 <a:solidFill>
                   <a:srgbClr val="CADCFC"/>
                 </a:solidFill>
-                <a:latin typeface="Calibri" pitchFamily="34" charset="0"/>
-                <a:ea typeface="Calibri" pitchFamily="34" charset="-122"/>
-                <a:cs typeface="Calibri" pitchFamily="34" charset="-120"/>
+                <a:ea typeface="Calibri" pitchFamily="34" charset="-122"/>
+                <a:cs typeface="Arial" panose="020B0604020202020204" pitchFamily="34" charset="0"/>
               </a:rPr>
               <a:t>Transaction Risk Data Warehouse</a:t>
             </a:r>
-            <a:endParaRPr lang="en-US" sz="2800" dirty="0"/>
-          </a:p>
-        </p:txBody>
-      </p:sp>
-      <p:sp>
-        <p:nvSpPr>
-          <p:cNvPr id="5" name="Text 3"/>
-          <p:cNvSpPr/>
-          <p:nvPr/>
-        </p:nvSpPr>
-        <p:spPr>
-          <a:xfrm>
-            <a:off x="731520" y="3538728"/>
+            <a:endParaRPr lang="en-US" sz="2800" dirty="0">
+              <a:cs typeface="Arial" panose="020B0604020202020204" pitchFamily="34" charset="0"/>
+            </a:endParaRPr>
+          </a:p>
+        </p:txBody>
+      </p:sp>
+      <p:sp>
+        <p:nvSpPr>
+          <p:cNvPr id="4" name="Text 2"/>
+          <p:cNvSpPr/>
+          <p:nvPr/>
+        </p:nvSpPr>
+        <p:spPr>
+          <a:xfrm>
+            <a:off x="731520" y="3474720"/>
             <a:ext cx="10698480" cy="457200"/>
           </a:xfrm>
           <a:prstGeom prst="rect">
@@ -1271,29 +1358,20 @@
               <a:buNone/>
             </a:pPr>
             <a:r>
-              <a:rPr lang="en-US" sz="2000" dirty="0" err="1" smtClean="0">
-                <a:solidFill>
-                  <a:schemeClr val="bg1"/>
-                </a:solidFill>
-                <a:latin typeface="Calibri" pitchFamily="34" charset="0"/>
-                <a:cs typeface="Calibri" pitchFamily="34" charset="-120"/>
-              </a:rPr>
-              <a:t>Sakthivel</a:t>
-            </a:r>
-            <a:r>
-              <a:rPr lang="en-US" sz="2000" dirty="0" smtClean="0">
-                <a:solidFill>
-                  <a:schemeClr val="bg1"/>
-                </a:solidFill>
-                <a:latin typeface="Calibri" pitchFamily="34" charset="0"/>
-                <a:cs typeface="Calibri" pitchFamily="34" charset="-120"/>
-              </a:rPr>
-              <a:t> R – Team 39</a:t>
-            </a:r>
-            <a:endParaRPr lang="en-US" sz="2000" dirty="0">
+              <a:rPr lang="en-US" sz="2800" dirty="0" smtClean="0">
+                <a:solidFill>
+                  <a:srgbClr val="00B0F0"/>
+                </a:solidFill>
+                <a:ea typeface="Calibri" pitchFamily="34" charset="-122"/>
+                <a:cs typeface="Arial" panose="020B0604020202020204" pitchFamily="34" charset="0"/>
+              </a:rPr>
+              <a:t>SAKTHIVEL R – Team 39</a:t>
+            </a:r>
+            <a:endParaRPr lang="en-US" sz="2800" dirty="0">
               <a:solidFill>
-                <a:schemeClr val="bg1"/>
+                <a:srgbClr val="00B0F0"/>
               </a:solidFill>
+              <a:cs typeface="Arial" panose="020B0604020202020204" pitchFamily="34" charset="0"/>
             </a:endParaRPr>
           </a:p>
         </p:txBody>
@@ -2148,7 +2226,6 @@
                 <a:solidFill>
                   <a:srgbClr val="1B3A5C"/>
                 </a:solidFill>
-                <a:latin typeface="Calibri" pitchFamily="34" charset="0"/>
                 <a:ea typeface="Calibri" pitchFamily="34" charset="-122"/>
                 <a:cs typeface="Calibri" pitchFamily="34" charset="-120"/>
               </a:rPr>
@@ -2166,7 +2243,7 @@
         </p:nvSpPr>
         <p:spPr>
           <a:xfrm>
-            <a:off x="365760" y="1280160"/>
+            <a:off x="795528" y="1280160"/>
             <a:ext cx="1737360" cy="1463040"/>
           </a:xfrm>
           <a:prstGeom prst="roundRect">
@@ -2195,7 +2272,7 @@
         </p:nvSpPr>
         <p:spPr>
           <a:xfrm>
-            <a:off x="365760" y="1371600"/>
+            <a:off x="822960" y="1371600"/>
             <a:ext cx="1737360" cy="457200"/>
           </a:xfrm>
           <a:prstGeom prst="rect">
@@ -2216,7 +2293,6 @@
                 <a:solidFill>
                   <a:srgbClr val="FFFFFF"/>
                 </a:solidFill>
-                <a:latin typeface="Calibri" pitchFamily="34" charset="0"/>
                 <a:ea typeface="Calibri" pitchFamily="34" charset="-122"/>
                 <a:cs typeface="Calibri" pitchFamily="34" charset="-120"/>
               </a:rPr>
@@ -2234,7 +2310,7 @@
         </p:nvSpPr>
         <p:spPr>
           <a:xfrm>
-            <a:off x="457200" y="1874520"/>
+            <a:off x="914400" y="1874520"/>
             <a:ext cx="1554480" cy="731520"/>
           </a:xfrm>
           <a:prstGeom prst="rect">
@@ -2257,7 +2333,6 @@
                     <a:alpha val="80000"/>
                   </a:srgbClr>
                 </a:solidFill>
-                <a:latin typeface="Calibri" pitchFamily="34" charset="0"/>
                 <a:ea typeface="Calibri" pitchFamily="34" charset="-122"/>
                 <a:cs typeface="Calibri" pitchFamily="34" charset="-120"/>
               </a:rPr>
@@ -2276,7 +2351,6 @@
                     <a:alpha val="80000"/>
                   </a:srgbClr>
                 </a:solidFill>
-                <a:latin typeface="Calibri" pitchFamily="34" charset="0"/>
                 <a:ea typeface="Calibri" pitchFamily="34" charset="-122"/>
                 <a:cs typeface="Calibri" pitchFamily="34" charset="-120"/>
               </a:rPr>
@@ -2294,7 +2368,7 @@
         </p:nvSpPr>
         <p:spPr>
           <a:xfrm>
-            <a:off x="2121408" y="1828800"/>
+            <a:off x="2560320" y="1828800"/>
             <a:ext cx="347472" cy="365760"/>
           </a:xfrm>
           <a:prstGeom prst="rightArrow">
@@ -2314,7 +2388,7 @@
         </p:nvSpPr>
         <p:spPr>
           <a:xfrm>
-            <a:off x="2468880" y="1280160"/>
+            <a:off x="2926080" y="1280160"/>
             <a:ext cx="1737360" cy="1463040"/>
           </a:xfrm>
           <a:prstGeom prst="roundRect">
@@ -2343,7 +2417,7 @@
         </p:nvSpPr>
         <p:spPr>
           <a:xfrm>
-            <a:off x="2468880" y="1371600"/>
+            <a:off x="2926080" y="1371600"/>
             <a:ext cx="1737360" cy="457200"/>
           </a:xfrm>
           <a:prstGeom prst="rect">
@@ -2364,7 +2438,6 @@
                 <a:solidFill>
                   <a:srgbClr val="FFFFFF"/>
                 </a:solidFill>
-                <a:latin typeface="Calibri" pitchFamily="34" charset="0"/>
                 <a:ea typeface="Calibri" pitchFamily="34" charset="-122"/>
                 <a:cs typeface="Calibri" pitchFamily="34" charset="-120"/>
               </a:rPr>
@@ -2382,7 +2455,7 @@
         </p:nvSpPr>
         <p:spPr>
           <a:xfrm>
-            <a:off x="2560320" y="1874520"/>
+            <a:off x="3017520" y="1874520"/>
             <a:ext cx="1554480" cy="731520"/>
           </a:xfrm>
           <a:prstGeom prst="rect">
@@ -2405,7 +2478,6 @@
                     <a:alpha val="80000"/>
                   </a:srgbClr>
                 </a:solidFill>
-                <a:latin typeface="Calibri" pitchFamily="34" charset="0"/>
                 <a:ea typeface="Calibri" pitchFamily="34" charset="-122"/>
                 <a:cs typeface="Calibri" pitchFamily="34" charset="-120"/>
               </a:rPr>
@@ -2424,7 +2496,6 @@
                     <a:alpha val="80000"/>
                   </a:srgbClr>
                 </a:solidFill>
-                <a:latin typeface="Calibri" pitchFamily="34" charset="0"/>
                 <a:ea typeface="Calibri" pitchFamily="34" charset="-122"/>
                 <a:cs typeface="Calibri" pitchFamily="34" charset="-120"/>
               </a:rPr>
@@ -2442,7 +2513,7 @@
         </p:nvSpPr>
         <p:spPr>
           <a:xfrm>
-            <a:off x="4224528" y="1828800"/>
+            <a:off x="4681728" y="1828800"/>
             <a:ext cx="347472" cy="365760"/>
           </a:xfrm>
           <a:prstGeom prst="rightArrow">
@@ -2462,7 +2533,7 @@
         </p:nvSpPr>
         <p:spPr>
           <a:xfrm>
-            <a:off x="4572000" y="1280160"/>
+            <a:off x="5029200" y="1280160"/>
             <a:ext cx="1737360" cy="1463040"/>
           </a:xfrm>
           <a:prstGeom prst="roundRect">
@@ -2491,7 +2562,7 @@
         </p:nvSpPr>
         <p:spPr>
           <a:xfrm>
-            <a:off x="4572000" y="1371600"/>
+            <a:off x="5029200" y="1371600"/>
             <a:ext cx="1737360" cy="457200"/>
           </a:xfrm>
           <a:prstGeom prst="rect">
@@ -2512,7 +2583,6 @@
                 <a:solidFill>
                   <a:srgbClr val="FFFFFF"/>
                 </a:solidFill>
-                <a:latin typeface="Calibri" pitchFamily="34" charset="0"/>
                 <a:ea typeface="Calibri" pitchFamily="34" charset="-122"/>
                 <a:cs typeface="Calibri" pitchFamily="34" charset="-120"/>
               </a:rPr>
@@ -2530,7 +2600,7 @@
         </p:nvSpPr>
         <p:spPr>
           <a:xfrm>
-            <a:off x="4663440" y="1874520"/>
+            <a:off x="5120640" y="1874520"/>
             <a:ext cx="1554480" cy="731520"/>
           </a:xfrm>
           <a:prstGeom prst="rect">
@@ -2553,7 +2623,6 @@
                     <a:alpha val="80000"/>
                   </a:srgbClr>
                 </a:solidFill>
-                <a:latin typeface="Calibri" pitchFamily="34" charset="0"/>
                 <a:ea typeface="Calibri" pitchFamily="34" charset="-122"/>
                 <a:cs typeface="Calibri" pitchFamily="34" charset="-120"/>
               </a:rPr>
@@ -2572,7 +2641,6 @@
                     <a:alpha val="80000"/>
                   </a:srgbClr>
                 </a:solidFill>
-                <a:latin typeface="Calibri" pitchFamily="34" charset="0"/>
                 <a:ea typeface="Calibri" pitchFamily="34" charset="-122"/>
                 <a:cs typeface="Calibri" pitchFamily="34" charset="-120"/>
               </a:rPr>
@@ -2590,7 +2658,7 @@
         </p:nvSpPr>
         <p:spPr>
           <a:xfrm>
-            <a:off x="6327648" y="1828800"/>
+            <a:off x="6784848" y="1828800"/>
             <a:ext cx="347472" cy="365760"/>
           </a:xfrm>
           <a:prstGeom prst="rightArrow">
@@ -2610,7 +2678,7 @@
         </p:nvSpPr>
         <p:spPr>
           <a:xfrm>
-            <a:off x="6675120" y="1280160"/>
+            <a:off x="7132320" y="1280160"/>
             <a:ext cx="1737360" cy="1463040"/>
           </a:xfrm>
           <a:prstGeom prst="roundRect">
@@ -2639,7 +2707,7 @@
         </p:nvSpPr>
         <p:spPr>
           <a:xfrm>
-            <a:off x="6675120" y="1371600"/>
+            <a:off x="7132320" y="1371600"/>
             <a:ext cx="1737360" cy="457200"/>
           </a:xfrm>
           <a:prstGeom prst="rect">
@@ -2660,7 +2728,6 @@
                 <a:solidFill>
                   <a:srgbClr val="FFFFFF"/>
                 </a:solidFill>
-                <a:latin typeface="Calibri" pitchFamily="34" charset="0"/>
                 <a:ea typeface="Calibri" pitchFamily="34" charset="-122"/>
                 <a:cs typeface="Calibri" pitchFamily="34" charset="-120"/>
               </a:rPr>
@@ -2678,7 +2745,7 @@
         </p:nvSpPr>
         <p:spPr>
           <a:xfrm>
-            <a:off x="6766560" y="1874520"/>
+            <a:off x="7223760" y="1874520"/>
             <a:ext cx="1554480" cy="731520"/>
           </a:xfrm>
           <a:prstGeom prst="rect">
@@ -2701,7 +2768,6 @@
                     <a:alpha val="80000"/>
                   </a:srgbClr>
                 </a:solidFill>
-                <a:latin typeface="Calibri" pitchFamily="34" charset="0"/>
                 <a:ea typeface="Calibri" pitchFamily="34" charset="-122"/>
                 <a:cs typeface="Calibri" pitchFamily="34" charset="-120"/>
               </a:rPr>
@@ -2720,7 +2786,6 @@
                     <a:alpha val="80000"/>
                   </a:srgbClr>
                 </a:solidFill>
-                <a:latin typeface="Calibri" pitchFamily="34" charset="0"/>
                 <a:ea typeface="Calibri" pitchFamily="34" charset="-122"/>
                 <a:cs typeface="Calibri" pitchFamily="34" charset="-120"/>
               </a:rPr>
@@ -2738,7 +2803,7 @@
         </p:nvSpPr>
         <p:spPr>
           <a:xfrm>
-            <a:off x="8430768" y="1828800"/>
+            <a:off x="8897112" y="1828800"/>
             <a:ext cx="347472" cy="365760"/>
           </a:xfrm>
           <a:prstGeom prst="rightArrow">
@@ -2758,7 +2823,7 @@
         </p:nvSpPr>
         <p:spPr>
           <a:xfrm>
-            <a:off x="8778240" y="1280160"/>
+            <a:off x="9272016" y="1280160"/>
             <a:ext cx="1737360" cy="1463040"/>
           </a:xfrm>
           <a:prstGeom prst="roundRect">
@@ -2787,7 +2852,7 @@
         </p:nvSpPr>
         <p:spPr>
           <a:xfrm>
-            <a:off x="8778240" y="1371600"/>
+            <a:off x="9272016" y="1371600"/>
             <a:ext cx="1737360" cy="457200"/>
           </a:xfrm>
           <a:prstGeom prst="rect">
@@ -2808,7 +2873,6 @@
                 <a:solidFill>
                   <a:srgbClr val="FFFFFF"/>
                 </a:solidFill>
-                <a:latin typeface="Calibri" pitchFamily="34" charset="0"/>
                 <a:ea typeface="Calibri" pitchFamily="34" charset="-122"/>
                 <a:cs typeface="Calibri" pitchFamily="34" charset="-120"/>
               </a:rPr>
@@ -2826,7 +2890,7 @@
         </p:nvSpPr>
         <p:spPr>
           <a:xfrm>
-            <a:off x="8869680" y="1874520"/>
+            <a:off x="9363456" y="1874520"/>
             <a:ext cx="1554480" cy="731520"/>
           </a:xfrm>
           <a:prstGeom prst="rect">
@@ -2849,7 +2913,6 @@
                     <a:alpha val="80000"/>
                   </a:srgbClr>
                 </a:solidFill>
-                <a:latin typeface="Calibri" pitchFamily="34" charset="0"/>
                 <a:ea typeface="Calibri" pitchFamily="34" charset="-122"/>
                 <a:cs typeface="Calibri" pitchFamily="34" charset="-120"/>
               </a:rPr>
@@ -2868,7 +2931,6 @@
                     <a:alpha val="80000"/>
                   </a:srgbClr>
                 </a:solidFill>
-                <a:latin typeface="Calibri" pitchFamily="34" charset="0"/>
                 <a:ea typeface="Calibri" pitchFamily="34" charset="-122"/>
                 <a:cs typeface="Calibri" pitchFamily="34" charset="-120"/>
               </a:rPr>
@@ -2906,7 +2968,7 @@
         </p:nvSpPr>
         <p:spPr>
           <a:xfrm>
-            <a:off x="4114800" y="3474720"/>
+            <a:off x="4434840" y="3497580"/>
             <a:ext cx="2560320" cy="822960"/>
           </a:xfrm>
           <a:prstGeom prst="roundRect">
@@ -2928,7 +2990,7 @@
         </p:nvSpPr>
         <p:spPr>
           <a:xfrm>
-            <a:off x="4114800" y="3520440"/>
+            <a:off x="4434840" y="3520440"/>
             <a:ext cx="2560320" cy="731520"/>
           </a:xfrm>
           <a:prstGeom prst="rect">
@@ -2949,7 +3011,6 @@
                 <a:solidFill>
                   <a:srgbClr val="FFFFFF"/>
                 </a:solidFill>
-                <a:latin typeface="Calibri" pitchFamily="34" charset="0"/>
                 <a:ea typeface="Calibri" pitchFamily="34" charset="-122"/>
                 <a:cs typeface="Calibri" pitchFamily="34" charset="-120"/>
               </a:rPr>
@@ -2966,7 +3027,6 @@
                 <a:solidFill>
                   <a:srgbClr val="FFFFFF"/>
                 </a:solidFill>
-                <a:latin typeface="Calibri" pitchFamily="34" charset="0"/>
                 <a:ea typeface="Calibri" pitchFamily="34" charset="-122"/>
                 <a:cs typeface="Calibri" pitchFamily="34" charset="-120"/>
               </a:rPr>
@@ -2984,7 +3044,7 @@
         </p:nvSpPr>
         <p:spPr>
           <a:xfrm>
-            <a:off x="5280660" y="2880360"/>
+            <a:off x="5650992" y="2834640"/>
             <a:ext cx="320040" cy="594360"/>
           </a:xfrm>
           <a:prstGeom prst="downArrow">
@@ -3004,7 +3064,7 @@
         </p:nvSpPr>
         <p:spPr>
           <a:xfrm>
-            <a:off x="2103120" y="4800600"/>
+            <a:off x="3108960" y="4754880"/>
             <a:ext cx="7772400" cy="1645920"/>
           </a:xfrm>
           <a:prstGeom prst="roundRect">
@@ -3031,7 +3091,7 @@
         </p:nvSpPr>
         <p:spPr>
           <a:xfrm>
-            <a:off x="2286000" y="4892040"/>
+            <a:off x="3291840" y="4846320"/>
             <a:ext cx="7315200" cy="365760"/>
           </a:xfrm>
           <a:prstGeom prst="rect">
@@ -3052,7 +3112,6 @@
                 <a:solidFill>
                   <a:srgbClr val="1B3A5C"/>
                 </a:solidFill>
-                <a:latin typeface="Calibri" pitchFamily="34" charset="0"/>
                 <a:ea typeface="Calibri" pitchFamily="34" charset="-122"/>
                 <a:cs typeface="Calibri" pitchFamily="34" charset="-120"/>
               </a:rPr>
@@ -3070,7 +3129,7 @@
         </p:nvSpPr>
         <p:spPr>
           <a:xfrm>
-            <a:off x="2377440" y="5394960"/>
+            <a:off x="3383280" y="5349240"/>
             <a:ext cx="2286000" cy="731520"/>
           </a:xfrm>
           <a:prstGeom prst="roundRect">
@@ -3092,7 +3151,7 @@
         </p:nvSpPr>
         <p:spPr>
           <a:xfrm>
-            <a:off x="2377440" y="5394960"/>
+            <a:off x="3383280" y="5394960"/>
             <a:ext cx="2286000" cy="640080"/>
           </a:xfrm>
           <a:prstGeom prst="rect">
@@ -3113,7 +3172,6 @@
                 <a:solidFill>
                   <a:srgbClr val="FFFFFF"/>
                 </a:solidFill>
-                <a:latin typeface="Calibri" pitchFamily="34" charset="0"/>
                 <a:ea typeface="Calibri" pitchFamily="34" charset="-122"/>
                 <a:cs typeface="Calibri" pitchFamily="34" charset="-120"/>
               </a:rPr>
@@ -3131,7 +3189,7 @@
         </p:nvSpPr>
         <p:spPr>
           <a:xfrm>
-            <a:off x="4937760" y="5349240"/>
+            <a:off x="5943600" y="5349240"/>
             <a:ext cx="2286000" cy="731520"/>
           </a:xfrm>
           <a:prstGeom prst="roundRect">
@@ -3153,7 +3211,7 @@
         </p:nvSpPr>
         <p:spPr>
           <a:xfrm>
-            <a:off x="4937760" y="5394960"/>
+            <a:off x="5943600" y="5394960"/>
             <a:ext cx="2286000" cy="640080"/>
           </a:xfrm>
           <a:prstGeom prst="rect">
@@ -3174,7 +3232,6 @@
                 <a:solidFill>
                   <a:srgbClr val="FFFFFF"/>
                 </a:solidFill>
-                <a:latin typeface="Calibri" pitchFamily="34" charset="0"/>
                 <a:ea typeface="Calibri" pitchFamily="34" charset="-122"/>
                 <a:cs typeface="Calibri" pitchFamily="34" charset="-120"/>
               </a:rPr>
@@ -3192,7 +3249,7 @@
         </p:nvSpPr>
         <p:spPr>
           <a:xfrm>
-            <a:off x="7498080" y="5349240"/>
+            <a:off x="8503920" y="5349240"/>
             <a:ext cx="2286000" cy="731520"/>
           </a:xfrm>
           <a:prstGeom prst="roundRect">
@@ -3214,7 +3271,7 @@
         </p:nvSpPr>
         <p:spPr>
           <a:xfrm>
-            <a:off x="7498080" y="5394960"/>
+            <a:off x="8503920" y="5394960"/>
             <a:ext cx="2286000" cy="640080"/>
           </a:xfrm>
           <a:prstGeom prst="rect">
@@ -3235,7 +3292,6 @@
                 <a:solidFill>
                   <a:srgbClr val="FFFFFF"/>
                 </a:solidFill>
-                <a:latin typeface="Calibri" pitchFamily="34" charset="0"/>
                 <a:ea typeface="Calibri" pitchFamily="34" charset="-122"/>
                 <a:cs typeface="Calibri" pitchFamily="34" charset="-120"/>
               </a:rPr>
@@ -3253,7 +3309,7 @@
         </p:nvSpPr>
         <p:spPr>
           <a:xfrm>
-            <a:off x="9281160" y="2834640"/>
+            <a:off x="9665208" y="2834640"/>
             <a:ext cx="320040" cy="1828800"/>
           </a:xfrm>
           <a:prstGeom prst="downArrow">
@@ -3261,6 +3317,171 @@
           </a:prstGeom>
           <a:solidFill>
             <a:srgbClr val="1B3A5C"/>
+          </a:solidFill>
+          <a:ln/>
+        </p:spPr>
+      </p:sp>
+      <p:sp>
+        <p:nvSpPr>
+          <p:cNvPr id="39" name="Shape 1"/>
+          <p:cNvSpPr/>
+          <p:nvPr/>
+        </p:nvSpPr>
+        <p:spPr>
+          <a:xfrm>
+            <a:off x="886968" y="4864608"/>
+            <a:ext cx="1737360" cy="1463040"/>
+          </a:xfrm>
+          <a:prstGeom prst="roundRect">
+            <a:avLst>
+              <a:gd name="adj" fmla="val 6250"/>
+            </a:avLst>
+          </a:prstGeom>
+          <a:solidFill>
+            <a:srgbClr val="7030A0"/>
+          </a:solidFill>
+          <a:ln/>
+          <a:effectLst>
+            <a:outerShdw blurRad="50800" dist="25400" dir="8100000" algn="bl" rotWithShape="0">
+              <a:srgbClr val="999999">
+                <a:alpha val="30000"/>
+              </a:srgbClr>
+            </a:outerShdw>
+          </a:effectLst>
+        </p:spPr>
+      </p:sp>
+      <p:sp>
+        <p:nvSpPr>
+          <p:cNvPr id="41" name="Text 2"/>
+          <p:cNvSpPr/>
+          <p:nvPr/>
+        </p:nvSpPr>
+        <p:spPr>
+          <a:xfrm>
+            <a:off x="886968" y="5172456"/>
+            <a:ext cx="1737360" cy="457200"/>
+          </a:xfrm>
+          <a:prstGeom prst="rect">
+            <a:avLst/>
+          </a:prstGeom>
+          <a:noFill/>
+          <a:ln/>
+        </p:spPr>
+        <p:txBody>
+          <a:bodyPr wrap="square" lIns="0" tIns="0" rIns="0" bIns="0" rtlCol="0" anchor="ctr"/>
+          <a:lstStyle/>
+          <a:p>
+            <a:pPr marL="0" indent="0" algn="ctr">
+              <a:buNone/>
+            </a:pPr>
+            <a:r>
+              <a:rPr lang="en-US" sz="1500" b="1" dirty="0" smtClean="0">
+                <a:solidFill>
+                  <a:srgbClr val="FFFFFF"/>
+                </a:solidFill>
+                <a:cs typeface="Calibri" pitchFamily="34" charset="-120"/>
+              </a:rPr>
+              <a:t>Query</a:t>
+            </a:r>
+            <a:endParaRPr lang="en-US" sz="1500" dirty="0"/>
+          </a:p>
+        </p:txBody>
+      </p:sp>
+      <p:sp>
+        <p:nvSpPr>
+          <p:cNvPr id="42" name="Text 3"/>
+          <p:cNvSpPr/>
+          <p:nvPr/>
+        </p:nvSpPr>
+        <p:spPr>
+          <a:xfrm>
+            <a:off x="950976" y="5413248"/>
+            <a:ext cx="1554480" cy="731520"/>
+          </a:xfrm>
+          <a:prstGeom prst="rect">
+            <a:avLst/>
+          </a:prstGeom>
+          <a:noFill/>
+          <a:ln/>
+        </p:spPr>
+        <p:txBody>
+          <a:bodyPr wrap="square" lIns="0" tIns="0" rIns="0" bIns="0" rtlCol="0" anchor="ctr"/>
+          <a:lstStyle/>
+          <a:p>
+            <a:pPr marL="0" indent="0" algn="ctr">
+              <a:buNone/>
+            </a:pPr>
+            <a:r>
+              <a:rPr lang="en-US" sz="1100" dirty="0">
+                <a:solidFill>
+                  <a:schemeClr val="bg1"/>
+                </a:solidFill>
+              </a:rPr>
+              <a:t>q</a:t>
+            </a:r>
+            <a:r>
+              <a:rPr lang="en-US" sz="1100" dirty="0" smtClean="0">
+                <a:solidFill>
+                  <a:schemeClr val="bg1"/>
+                </a:solidFill>
+              </a:rPr>
+              <a:t>uery.py</a:t>
+            </a:r>
+            <a:endParaRPr lang="en-US" sz="1100" dirty="0">
+              <a:solidFill>
+                <a:schemeClr val="bg1"/>
+              </a:solidFill>
+            </a:endParaRPr>
+          </a:p>
+          <a:p>
+            <a:pPr marL="0" indent="0" algn="ctr">
+              <a:buNone/>
+            </a:pPr>
+            <a:r>
+              <a:rPr lang="en-US" sz="1100" dirty="0">
+                <a:solidFill>
+                  <a:schemeClr val="bg1"/>
+                </a:solidFill>
+                <a:cs typeface="Calibri" pitchFamily="34" charset="-120"/>
+              </a:rPr>
+              <a:t>r</a:t>
+            </a:r>
+            <a:r>
+              <a:rPr lang="en-US" sz="1100" dirty="0" smtClean="0">
+                <a:solidFill>
+                  <a:schemeClr val="bg1"/>
+                </a:solidFill>
+                <a:cs typeface="Calibri" pitchFamily="34" charset="-120"/>
+              </a:rPr>
+              <a:t>isk analysis</a:t>
+            </a:r>
+            <a:endParaRPr lang="en-US" sz="1100" dirty="0">
+              <a:solidFill>
+                <a:schemeClr val="bg1"/>
+              </a:solidFill>
+            </a:endParaRPr>
+          </a:p>
+        </p:txBody>
+      </p:sp>
+      <p:sp>
+        <p:nvSpPr>
+          <p:cNvPr id="46" name="Shape 4"/>
+          <p:cNvSpPr/>
+          <p:nvPr/>
+        </p:nvSpPr>
+        <p:spPr>
+          <a:xfrm rot="10800000">
+            <a:off x="2638044" y="5475732"/>
+            <a:ext cx="429768" cy="350520"/>
+          </a:xfrm>
+          <a:prstGeom prst="rightArrow">
+            <a:avLst/>
+          </a:prstGeom>
+          <a:solidFill>
+            <a:schemeClr val="tx1">
+              <a:lumMod val="75000"/>
+              <a:lumOff val="25000"/>
+            </a:schemeClr>
           </a:solidFill>
           <a:ln/>
         </p:spPr>
@@ -6370,6 +6591,1074 @@
 </file>
 
 <file path=ppt/slides/slide7.xml><?xml version="1.0" encoding="utf-8"?>
+<p:sld xmlns:a="http://schemas.openxmlformats.org/drawingml/2006/main" xmlns:r="http://schemas.openxmlformats.org/officeDocument/2006/relationships" xmlns:p="http://schemas.openxmlformats.org/presentationml/2006/main">
+  <p:cSld name="Slide 7">
+    <p:bg>
+      <p:bgPr>
+        <a:solidFill>
+          <a:srgbClr val="FFFFFF"/>
+        </a:solidFill>
+        <a:effectLst/>
+      </p:bgPr>
+    </p:bg>
+    <p:spTree>
+      <p:nvGrpSpPr>
+        <p:cNvPr id="1" name=""/>
+        <p:cNvGrpSpPr/>
+        <p:nvPr/>
+      </p:nvGrpSpPr>
+      <p:grpSpPr>
+        <a:xfrm>
+          <a:off x="0" y="0"/>
+          <a:ext cx="0" cy="0"/>
+          <a:chOff x="0" y="0"/>
+          <a:chExt cx="0" cy="0"/>
+        </a:xfrm>
+      </p:grpSpPr>
+      <p:sp>
+        <p:nvSpPr>
+          <p:cNvPr id="2" name="Text 0"/>
+          <p:cNvSpPr/>
+          <p:nvPr/>
+        </p:nvSpPr>
+        <p:spPr>
+          <a:xfrm>
+            <a:off x="731520" y="274320"/>
+            <a:ext cx="10698480" cy="640080"/>
+          </a:xfrm>
+          <a:prstGeom prst="rect">
+            <a:avLst/>
+          </a:prstGeom>
+          <a:noFill/>
+          <a:ln/>
+        </p:spPr>
+        <p:txBody>
+          <a:bodyPr wrap="square" lIns="0" tIns="0" rIns="0" bIns="0" rtlCol="0" anchor="ctr"/>
+          <a:lstStyle/>
+          <a:p>
+            <a:pPr marL="0" indent="0" algn="l">
+              <a:buNone/>
+            </a:pPr>
+            <a:r>
+              <a:rPr lang="en-US" sz="3600" b="1" dirty="0">
+                <a:solidFill>
+                  <a:srgbClr val="1B3A5C"/>
+                </a:solidFill>
+                <a:latin typeface="Calibri" pitchFamily="34" charset="0"/>
+                <a:ea typeface="Calibri" pitchFamily="34" charset="-122"/>
+                <a:cs typeface="Calibri" pitchFamily="34" charset="-120"/>
+              </a:rPr>
+              <a:t>Tech Stack</a:t>
+            </a:r>
+            <a:endParaRPr lang="en-US" sz="3600" dirty="0"/>
+          </a:p>
+        </p:txBody>
+      </p:sp>
+      <p:sp>
+        <p:nvSpPr>
+          <p:cNvPr id="3" name="Shape 1"/>
+          <p:cNvSpPr/>
+          <p:nvPr/>
+        </p:nvSpPr>
+        <p:spPr>
+          <a:xfrm>
+            <a:off x="548640" y="1371600"/>
+            <a:ext cx="3520440" cy="2011680"/>
+          </a:xfrm>
+          <a:prstGeom prst="roundRect">
+            <a:avLst>
+              <a:gd name="adj" fmla="val 4545"/>
+            </a:avLst>
+          </a:prstGeom>
+          <a:solidFill>
+            <a:srgbClr val="F4F6F9"/>
+          </a:solidFill>
+          <a:ln/>
+          <a:effectLst>
+            <a:outerShdw blurRad="38100" dist="12700" dir="8100000" algn="bl" rotWithShape="0">
+              <a:srgbClr val="CCCCCC">
+                <a:alpha val="30000"/>
+              </a:srgbClr>
+            </a:outerShdw>
+          </a:effectLst>
+        </p:spPr>
+      </p:sp>
+      <p:sp>
+        <p:nvSpPr>
+          <p:cNvPr id="4" name="Shape 2"/>
+          <p:cNvSpPr/>
+          <p:nvPr/>
+        </p:nvSpPr>
+        <p:spPr>
+          <a:xfrm>
+            <a:off x="1828800" y="1600200"/>
+            <a:ext cx="914400" cy="914400"/>
+          </a:xfrm>
+          <a:prstGeom prst="ellipse">
+            <a:avLst/>
+          </a:prstGeom>
+          <a:solidFill>
+            <a:srgbClr val="2E75B6"/>
+          </a:solidFill>
+          <a:ln/>
+        </p:spPr>
+      </p:sp>
+      <p:sp>
+        <p:nvSpPr>
+          <p:cNvPr id="5" name="Text 3"/>
+          <p:cNvSpPr/>
+          <p:nvPr/>
+        </p:nvSpPr>
+        <p:spPr>
+          <a:xfrm>
+            <a:off x="1828800" y="1600200"/>
+            <a:ext cx="914400" cy="914400"/>
+          </a:xfrm>
+          <a:prstGeom prst="rect">
+            <a:avLst/>
+          </a:prstGeom>
+          <a:noFill/>
+          <a:ln/>
+        </p:spPr>
+        <p:txBody>
+          <a:bodyPr wrap="square" lIns="0" tIns="0" rIns="0" bIns="0" rtlCol="0" anchor="ctr"/>
+          <a:lstStyle/>
+          <a:p>
+            <a:pPr marL="0" indent="0" algn="ctr">
+              <a:buNone/>
+            </a:pPr>
+            <a:r>
+              <a:rPr lang="en-US" sz="2800" b="1" dirty="0">
+                <a:solidFill>
+                  <a:srgbClr val="FFFFFF"/>
+                </a:solidFill>
+                <a:latin typeface="Calibri" pitchFamily="34" charset="0"/>
+                <a:ea typeface="Calibri" pitchFamily="34" charset="-122"/>
+                <a:cs typeface="Calibri" pitchFamily="34" charset="-120"/>
+              </a:rPr>
+              <a:t>P</a:t>
+            </a:r>
+            <a:endParaRPr lang="en-US" sz="2800" dirty="0"/>
+          </a:p>
+        </p:txBody>
+      </p:sp>
+      <p:sp>
+        <p:nvSpPr>
+          <p:cNvPr id="6" name="Text 4"/>
+          <p:cNvSpPr/>
+          <p:nvPr/>
+        </p:nvSpPr>
+        <p:spPr>
+          <a:xfrm>
+            <a:off x="731520" y="2606040"/>
+            <a:ext cx="3154680" cy="365760"/>
+          </a:xfrm>
+          <a:prstGeom prst="rect">
+            <a:avLst/>
+          </a:prstGeom>
+          <a:noFill/>
+          <a:ln/>
+        </p:spPr>
+        <p:txBody>
+          <a:bodyPr wrap="square" lIns="0" tIns="0" rIns="0" bIns="0" rtlCol="0" anchor="ctr"/>
+          <a:lstStyle/>
+          <a:p>
+            <a:pPr marL="0" indent="0" algn="ctr">
+              <a:buNone/>
+            </a:pPr>
+            <a:r>
+              <a:rPr lang="en-US" sz="1600" b="1" dirty="0">
+                <a:solidFill>
+                  <a:srgbClr val="1B3A5C"/>
+                </a:solidFill>
+                <a:latin typeface="Calibri" pitchFamily="34" charset="0"/>
+                <a:ea typeface="Calibri" pitchFamily="34" charset="-122"/>
+                <a:cs typeface="Calibri" pitchFamily="34" charset="-120"/>
+              </a:rPr>
+              <a:t>Python 3</a:t>
+            </a:r>
+            <a:endParaRPr lang="en-US" sz="1600" dirty="0"/>
+          </a:p>
+        </p:txBody>
+      </p:sp>
+      <p:sp>
+        <p:nvSpPr>
+          <p:cNvPr id="7" name="Text 5"/>
+          <p:cNvSpPr/>
+          <p:nvPr/>
+        </p:nvSpPr>
+        <p:spPr>
+          <a:xfrm>
+            <a:off x="731520" y="2926080"/>
+            <a:ext cx="3154680" cy="320040"/>
+          </a:xfrm>
+          <a:prstGeom prst="rect">
+            <a:avLst/>
+          </a:prstGeom>
+          <a:noFill/>
+          <a:ln/>
+        </p:spPr>
+        <p:txBody>
+          <a:bodyPr wrap="square" lIns="0" tIns="0" rIns="0" bIns="0" rtlCol="0" anchor="ctr"/>
+          <a:lstStyle/>
+          <a:p>
+            <a:pPr marL="0" indent="0" algn="ctr">
+              <a:buNone/>
+            </a:pPr>
+            <a:r>
+              <a:rPr lang="en-US" sz="1200" dirty="0">
+                <a:solidFill>
+                  <a:srgbClr val="6B7B8D"/>
+                </a:solidFill>
+                <a:latin typeface="Calibri" pitchFamily="34" charset="0"/>
+                <a:ea typeface="Calibri" pitchFamily="34" charset="-122"/>
+                <a:cs typeface="Calibri" pitchFamily="34" charset="-120"/>
+              </a:rPr>
+              <a:t>Pipeline orchestration</a:t>
+            </a:r>
+            <a:endParaRPr lang="en-US" sz="1200" dirty="0"/>
+          </a:p>
+        </p:txBody>
+      </p:sp>
+      <p:sp>
+        <p:nvSpPr>
+          <p:cNvPr id="8" name="Shape 6"/>
+          <p:cNvSpPr/>
+          <p:nvPr/>
+        </p:nvSpPr>
+        <p:spPr>
+          <a:xfrm>
+            <a:off x="4343400" y="1371600"/>
+            <a:ext cx="3520440" cy="2011680"/>
+          </a:xfrm>
+          <a:prstGeom prst="roundRect">
+            <a:avLst>
+              <a:gd name="adj" fmla="val 4545"/>
+            </a:avLst>
+          </a:prstGeom>
+          <a:solidFill>
+            <a:srgbClr val="F4F6F9"/>
+          </a:solidFill>
+          <a:ln/>
+          <a:effectLst>
+            <a:outerShdw blurRad="38100" dist="12700" dir="8100000" algn="bl" rotWithShape="0">
+              <a:srgbClr val="CCCCCC">
+                <a:alpha val="30000"/>
+              </a:srgbClr>
+            </a:outerShdw>
+          </a:effectLst>
+        </p:spPr>
+      </p:sp>
+      <p:sp>
+        <p:nvSpPr>
+          <p:cNvPr id="9" name="Shape 7"/>
+          <p:cNvSpPr/>
+          <p:nvPr/>
+        </p:nvSpPr>
+        <p:spPr>
+          <a:xfrm>
+            <a:off x="5623560" y="1600200"/>
+            <a:ext cx="914400" cy="914400"/>
+          </a:xfrm>
+          <a:prstGeom prst="ellipse">
+            <a:avLst/>
+          </a:prstGeom>
+          <a:solidFill>
+            <a:srgbClr val="2D8B55"/>
+          </a:solidFill>
+          <a:ln/>
+        </p:spPr>
+      </p:sp>
+      <p:sp>
+        <p:nvSpPr>
+          <p:cNvPr id="10" name="Text 8"/>
+          <p:cNvSpPr/>
+          <p:nvPr/>
+        </p:nvSpPr>
+        <p:spPr>
+          <a:xfrm>
+            <a:off x="5623560" y="1600200"/>
+            <a:ext cx="914400" cy="914400"/>
+          </a:xfrm>
+          <a:prstGeom prst="rect">
+            <a:avLst/>
+          </a:prstGeom>
+          <a:noFill/>
+          <a:ln/>
+        </p:spPr>
+        <p:txBody>
+          <a:bodyPr wrap="square" lIns="0" tIns="0" rIns="0" bIns="0" rtlCol="0" anchor="ctr"/>
+          <a:lstStyle/>
+          <a:p>
+            <a:pPr marL="0" indent="0" algn="ctr">
+              <a:buNone/>
+            </a:pPr>
+            <a:r>
+              <a:rPr lang="en-US" sz="2800" b="1" dirty="0">
+                <a:solidFill>
+                  <a:srgbClr val="FFFFFF"/>
+                </a:solidFill>
+                <a:latin typeface="Calibri" pitchFamily="34" charset="0"/>
+                <a:ea typeface="Calibri" pitchFamily="34" charset="-122"/>
+                <a:cs typeface="Calibri" pitchFamily="34" charset="-120"/>
+              </a:rPr>
+              <a:t>P</a:t>
+            </a:r>
+            <a:endParaRPr lang="en-US" sz="2800" dirty="0"/>
+          </a:p>
+        </p:txBody>
+      </p:sp>
+      <p:sp>
+        <p:nvSpPr>
+          <p:cNvPr id="11" name="Text 9"/>
+          <p:cNvSpPr/>
+          <p:nvPr/>
+        </p:nvSpPr>
+        <p:spPr>
+          <a:xfrm>
+            <a:off x="4526280" y="2606040"/>
+            <a:ext cx="3154680" cy="365760"/>
+          </a:xfrm>
+          <a:prstGeom prst="rect">
+            <a:avLst/>
+          </a:prstGeom>
+          <a:noFill/>
+          <a:ln/>
+        </p:spPr>
+        <p:txBody>
+          <a:bodyPr wrap="square" lIns="0" tIns="0" rIns="0" bIns="0" rtlCol="0" anchor="ctr"/>
+          <a:lstStyle/>
+          <a:p>
+            <a:pPr marL="0" indent="0" algn="ctr">
+              <a:buNone/>
+            </a:pPr>
+            <a:r>
+              <a:rPr lang="en-US" sz="1600" b="1" dirty="0">
+                <a:solidFill>
+                  <a:srgbClr val="1B3A5C"/>
+                </a:solidFill>
+                <a:latin typeface="Calibri" pitchFamily="34" charset="0"/>
+                <a:ea typeface="Calibri" pitchFamily="34" charset="-122"/>
+                <a:cs typeface="Calibri" pitchFamily="34" charset="-120"/>
+              </a:rPr>
+              <a:t>pandas</a:t>
+            </a:r>
+            <a:endParaRPr lang="en-US" sz="1600" dirty="0"/>
+          </a:p>
+        </p:txBody>
+      </p:sp>
+      <p:sp>
+        <p:nvSpPr>
+          <p:cNvPr id="12" name="Text 10"/>
+          <p:cNvSpPr/>
+          <p:nvPr/>
+        </p:nvSpPr>
+        <p:spPr>
+          <a:xfrm>
+            <a:off x="4526280" y="2926080"/>
+            <a:ext cx="3154680" cy="320040"/>
+          </a:xfrm>
+          <a:prstGeom prst="rect">
+            <a:avLst/>
+          </a:prstGeom>
+          <a:noFill/>
+          <a:ln/>
+        </p:spPr>
+        <p:txBody>
+          <a:bodyPr wrap="square" lIns="0" tIns="0" rIns="0" bIns="0" rtlCol="0" anchor="ctr"/>
+          <a:lstStyle/>
+          <a:p>
+            <a:pPr marL="0" indent="0" algn="ctr">
+              <a:buNone/>
+            </a:pPr>
+            <a:r>
+              <a:rPr lang="en-US" sz="1200" dirty="0">
+                <a:solidFill>
+                  <a:srgbClr val="6B7B8D"/>
+                </a:solidFill>
+                <a:latin typeface="Calibri" pitchFamily="34" charset="0"/>
+                <a:ea typeface="Calibri" pitchFamily="34" charset="-122"/>
+                <a:cs typeface="Calibri" pitchFamily="34" charset="-120"/>
+              </a:rPr>
+              <a:t>Cleaning, validation, transformation</a:t>
+            </a:r>
+            <a:endParaRPr lang="en-US" sz="1200" dirty="0"/>
+          </a:p>
+        </p:txBody>
+      </p:sp>
+      <p:sp>
+        <p:nvSpPr>
+          <p:cNvPr id="13" name="Shape 11"/>
+          <p:cNvSpPr/>
+          <p:nvPr/>
+        </p:nvSpPr>
+        <p:spPr>
+          <a:xfrm>
+            <a:off x="8138160" y="1371600"/>
+            <a:ext cx="3520440" cy="2011680"/>
+          </a:xfrm>
+          <a:prstGeom prst="roundRect">
+            <a:avLst>
+              <a:gd name="adj" fmla="val 4545"/>
+            </a:avLst>
+          </a:prstGeom>
+          <a:solidFill>
+            <a:srgbClr val="F4F6F9"/>
+          </a:solidFill>
+          <a:ln/>
+          <a:effectLst>
+            <a:outerShdw blurRad="38100" dist="12700" dir="8100000" algn="bl" rotWithShape="0">
+              <a:srgbClr val="CCCCCC">
+                <a:alpha val="30000"/>
+              </a:srgbClr>
+            </a:outerShdw>
+          </a:effectLst>
+        </p:spPr>
+      </p:sp>
+      <p:sp>
+        <p:nvSpPr>
+          <p:cNvPr id="14" name="Shape 12"/>
+          <p:cNvSpPr/>
+          <p:nvPr/>
+        </p:nvSpPr>
+        <p:spPr>
+          <a:xfrm>
+            <a:off x="9418320" y="1600200"/>
+            <a:ext cx="914400" cy="914400"/>
+          </a:xfrm>
+          <a:prstGeom prst="ellipse">
+            <a:avLst/>
+          </a:prstGeom>
+          <a:solidFill>
+            <a:srgbClr val="E67E22"/>
+          </a:solidFill>
+          <a:ln/>
+        </p:spPr>
+      </p:sp>
+      <p:sp>
+        <p:nvSpPr>
+          <p:cNvPr id="15" name="Text 13"/>
+          <p:cNvSpPr/>
+          <p:nvPr/>
+        </p:nvSpPr>
+        <p:spPr>
+          <a:xfrm>
+            <a:off x="9418320" y="1600200"/>
+            <a:ext cx="914400" cy="914400"/>
+          </a:xfrm>
+          <a:prstGeom prst="rect">
+            <a:avLst/>
+          </a:prstGeom>
+          <a:noFill/>
+          <a:ln/>
+        </p:spPr>
+        <p:txBody>
+          <a:bodyPr wrap="square" lIns="0" tIns="0" rIns="0" bIns="0" rtlCol="0" anchor="ctr"/>
+          <a:lstStyle/>
+          <a:p>
+            <a:pPr marL="0" indent="0" algn="ctr">
+              <a:buNone/>
+            </a:pPr>
+            <a:r>
+              <a:rPr lang="en-US" sz="2800" b="1" dirty="0">
+                <a:solidFill>
+                  <a:srgbClr val="FFFFFF"/>
+                </a:solidFill>
+                <a:latin typeface="Calibri" pitchFamily="34" charset="0"/>
+                <a:ea typeface="Calibri" pitchFamily="34" charset="-122"/>
+                <a:cs typeface="Calibri" pitchFamily="34" charset="-120"/>
+              </a:rPr>
+              <a:t>O</a:t>
+            </a:r>
+            <a:endParaRPr lang="en-US" sz="2800" dirty="0"/>
+          </a:p>
+        </p:txBody>
+      </p:sp>
+      <p:sp>
+        <p:nvSpPr>
+          <p:cNvPr id="16" name="Text 14"/>
+          <p:cNvSpPr/>
+          <p:nvPr/>
+        </p:nvSpPr>
+        <p:spPr>
+          <a:xfrm>
+            <a:off x="8321040" y="2606040"/>
+            <a:ext cx="3154680" cy="365760"/>
+          </a:xfrm>
+          <a:prstGeom prst="rect">
+            <a:avLst/>
+          </a:prstGeom>
+          <a:noFill/>
+          <a:ln/>
+        </p:spPr>
+        <p:txBody>
+          <a:bodyPr wrap="square" lIns="0" tIns="0" rIns="0" bIns="0" rtlCol="0" anchor="ctr"/>
+          <a:lstStyle/>
+          <a:p>
+            <a:pPr marL="0" indent="0" algn="ctr">
+              <a:buNone/>
+            </a:pPr>
+            <a:r>
+              <a:rPr lang="en-US" sz="1600" b="1" dirty="0">
+                <a:solidFill>
+                  <a:srgbClr val="1B3A5C"/>
+                </a:solidFill>
+                <a:latin typeface="Calibri" pitchFamily="34" charset="0"/>
+                <a:ea typeface="Calibri" pitchFamily="34" charset="-122"/>
+                <a:cs typeface="Calibri" pitchFamily="34" charset="-120"/>
+              </a:rPr>
+              <a:t>oracledb</a:t>
+            </a:r>
+            <a:endParaRPr lang="en-US" sz="1600" dirty="0"/>
+          </a:p>
+        </p:txBody>
+      </p:sp>
+      <p:sp>
+        <p:nvSpPr>
+          <p:cNvPr id="17" name="Text 15"/>
+          <p:cNvSpPr/>
+          <p:nvPr/>
+        </p:nvSpPr>
+        <p:spPr>
+          <a:xfrm>
+            <a:off x="8321040" y="2926080"/>
+            <a:ext cx="3154680" cy="320040"/>
+          </a:xfrm>
+          <a:prstGeom prst="rect">
+            <a:avLst/>
+          </a:prstGeom>
+          <a:noFill/>
+          <a:ln/>
+        </p:spPr>
+        <p:txBody>
+          <a:bodyPr wrap="square" lIns="0" tIns="0" rIns="0" bIns="0" rtlCol="0" anchor="ctr"/>
+          <a:lstStyle/>
+          <a:p>
+            <a:pPr marL="0" indent="0" algn="ctr">
+              <a:buNone/>
+            </a:pPr>
+            <a:r>
+              <a:rPr lang="en-US" sz="1200" dirty="0">
+                <a:solidFill>
+                  <a:srgbClr val="6B7B8D"/>
+                </a:solidFill>
+                <a:latin typeface="Calibri" pitchFamily="34" charset="0"/>
+                <a:ea typeface="Calibri" pitchFamily="34" charset="-122"/>
+                <a:cs typeface="Calibri" pitchFamily="34" charset="-120"/>
+              </a:rPr>
+              <a:t>Database connectivity</a:t>
+            </a:r>
+            <a:endParaRPr lang="en-US" sz="1200" dirty="0"/>
+          </a:p>
+        </p:txBody>
+      </p:sp>
+      <p:sp>
+        <p:nvSpPr>
+          <p:cNvPr id="18" name="Shape 16"/>
+          <p:cNvSpPr/>
+          <p:nvPr/>
+        </p:nvSpPr>
+        <p:spPr>
+          <a:xfrm>
+            <a:off x="548640" y="3931920"/>
+            <a:ext cx="3520440" cy="2011680"/>
+          </a:xfrm>
+          <a:prstGeom prst="roundRect">
+            <a:avLst>
+              <a:gd name="adj" fmla="val 4545"/>
+            </a:avLst>
+          </a:prstGeom>
+          <a:solidFill>
+            <a:srgbClr val="F4F6F9"/>
+          </a:solidFill>
+          <a:ln/>
+          <a:effectLst>
+            <a:outerShdw blurRad="38100" dist="12700" dir="8100000" algn="bl" rotWithShape="0">
+              <a:srgbClr val="CCCCCC">
+                <a:alpha val="30000"/>
+              </a:srgbClr>
+            </a:outerShdw>
+          </a:effectLst>
+        </p:spPr>
+      </p:sp>
+      <p:sp>
+        <p:nvSpPr>
+          <p:cNvPr id="19" name="Shape 17"/>
+          <p:cNvSpPr/>
+          <p:nvPr/>
+        </p:nvSpPr>
+        <p:spPr>
+          <a:xfrm>
+            <a:off x="1828800" y="4160520"/>
+            <a:ext cx="914400" cy="914400"/>
+          </a:xfrm>
+          <a:prstGeom prst="ellipse">
+            <a:avLst/>
+          </a:prstGeom>
+          <a:solidFill>
+            <a:srgbClr val="1B3A5C"/>
+          </a:solidFill>
+          <a:ln/>
+        </p:spPr>
+      </p:sp>
+      <p:sp>
+        <p:nvSpPr>
+          <p:cNvPr id="20" name="Text 18"/>
+          <p:cNvSpPr/>
+          <p:nvPr/>
+        </p:nvSpPr>
+        <p:spPr>
+          <a:xfrm>
+            <a:off x="1828800" y="4160520"/>
+            <a:ext cx="914400" cy="914400"/>
+          </a:xfrm>
+          <a:prstGeom prst="rect">
+            <a:avLst/>
+          </a:prstGeom>
+          <a:noFill/>
+          <a:ln/>
+        </p:spPr>
+        <p:txBody>
+          <a:bodyPr wrap="square" lIns="0" tIns="0" rIns="0" bIns="0" rtlCol="0" anchor="ctr"/>
+          <a:lstStyle/>
+          <a:p>
+            <a:pPr marL="0" indent="0" algn="ctr">
+              <a:buNone/>
+            </a:pPr>
+            <a:r>
+              <a:rPr lang="en-US" sz="2800" b="1" dirty="0">
+                <a:solidFill>
+                  <a:srgbClr val="FFFFFF"/>
+                </a:solidFill>
+                <a:latin typeface="Calibri" pitchFamily="34" charset="0"/>
+                <a:ea typeface="Calibri" pitchFamily="34" charset="-122"/>
+                <a:cs typeface="Calibri" pitchFamily="34" charset="-120"/>
+              </a:rPr>
+              <a:t>O</a:t>
+            </a:r>
+            <a:endParaRPr lang="en-US" sz="2800" dirty="0"/>
+          </a:p>
+        </p:txBody>
+      </p:sp>
+      <p:sp>
+        <p:nvSpPr>
+          <p:cNvPr id="21" name="Text 19"/>
+          <p:cNvSpPr/>
+          <p:nvPr/>
+        </p:nvSpPr>
+        <p:spPr>
+          <a:xfrm>
+            <a:off x="731520" y="5166360"/>
+            <a:ext cx="3154680" cy="365760"/>
+          </a:xfrm>
+          <a:prstGeom prst="rect">
+            <a:avLst/>
+          </a:prstGeom>
+          <a:noFill/>
+          <a:ln/>
+        </p:spPr>
+        <p:txBody>
+          <a:bodyPr wrap="square" lIns="0" tIns="0" rIns="0" bIns="0" rtlCol="0" anchor="ctr"/>
+          <a:lstStyle/>
+          <a:p>
+            <a:pPr marL="0" indent="0" algn="ctr">
+              <a:buNone/>
+            </a:pPr>
+            <a:r>
+              <a:rPr lang="en-US" sz="1600" b="1" dirty="0">
+                <a:solidFill>
+                  <a:srgbClr val="1B3A5C"/>
+                </a:solidFill>
+                <a:latin typeface="Calibri" pitchFamily="34" charset="0"/>
+                <a:ea typeface="Calibri" pitchFamily="34" charset="-122"/>
+                <a:cs typeface="Calibri" pitchFamily="34" charset="-120"/>
+              </a:rPr>
+              <a:t>Oracle DB</a:t>
+            </a:r>
+            <a:endParaRPr lang="en-US" sz="1600" dirty="0"/>
+          </a:p>
+        </p:txBody>
+      </p:sp>
+      <p:sp>
+        <p:nvSpPr>
+          <p:cNvPr id="22" name="Text 20"/>
+          <p:cNvSpPr/>
+          <p:nvPr/>
+        </p:nvSpPr>
+        <p:spPr>
+          <a:xfrm>
+            <a:off x="731520" y="5486400"/>
+            <a:ext cx="3154680" cy="320040"/>
+          </a:xfrm>
+          <a:prstGeom prst="rect">
+            <a:avLst/>
+          </a:prstGeom>
+          <a:noFill/>
+          <a:ln/>
+        </p:spPr>
+        <p:txBody>
+          <a:bodyPr wrap="square" lIns="0" tIns="0" rIns="0" bIns="0" rtlCol="0" anchor="ctr"/>
+          <a:lstStyle/>
+          <a:p>
+            <a:pPr marL="0" indent="0" algn="ctr">
+              <a:buNone/>
+            </a:pPr>
+            <a:r>
+              <a:rPr lang="en-US" sz="1200" dirty="0">
+                <a:solidFill>
+                  <a:srgbClr val="6B7B8D"/>
+                </a:solidFill>
+                <a:latin typeface="Calibri" pitchFamily="34" charset="0"/>
+                <a:ea typeface="Calibri" pitchFamily="34" charset="-122"/>
+                <a:cs typeface="Calibri" pitchFamily="34" charset="-120"/>
+              </a:rPr>
+              <a:t>Warehouse storage and queries</a:t>
+            </a:r>
+            <a:endParaRPr lang="en-US" sz="1200" dirty="0"/>
+          </a:p>
+        </p:txBody>
+      </p:sp>
+      <p:sp>
+        <p:nvSpPr>
+          <p:cNvPr id="23" name="Shape 21"/>
+          <p:cNvSpPr/>
+          <p:nvPr/>
+        </p:nvSpPr>
+        <p:spPr>
+          <a:xfrm>
+            <a:off x="4343400" y="3931920"/>
+            <a:ext cx="3520440" cy="2011680"/>
+          </a:xfrm>
+          <a:prstGeom prst="roundRect">
+            <a:avLst>
+              <a:gd name="adj" fmla="val 4545"/>
+            </a:avLst>
+          </a:prstGeom>
+          <a:solidFill>
+            <a:srgbClr val="F4F6F9"/>
+          </a:solidFill>
+          <a:ln/>
+          <a:effectLst>
+            <a:outerShdw blurRad="38100" dist="12700" dir="8100000" algn="bl" rotWithShape="0">
+              <a:srgbClr val="CCCCCC">
+                <a:alpha val="30000"/>
+              </a:srgbClr>
+            </a:outerShdw>
+          </a:effectLst>
+        </p:spPr>
+      </p:sp>
+      <p:sp>
+        <p:nvSpPr>
+          <p:cNvPr id="24" name="Shape 22"/>
+          <p:cNvSpPr/>
+          <p:nvPr/>
+        </p:nvSpPr>
+        <p:spPr>
+          <a:xfrm>
+            <a:off x="5623560" y="4160520"/>
+            <a:ext cx="914400" cy="914400"/>
+          </a:xfrm>
+          <a:prstGeom prst="ellipse">
+            <a:avLst/>
+          </a:prstGeom>
+          <a:solidFill>
+            <a:srgbClr val="6B7B8D"/>
+          </a:solidFill>
+          <a:ln/>
+        </p:spPr>
+      </p:sp>
+      <p:sp>
+        <p:nvSpPr>
+          <p:cNvPr id="25" name="Text 23"/>
+          <p:cNvSpPr/>
+          <p:nvPr/>
+        </p:nvSpPr>
+        <p:spPr>
+          <a:xfrm>
+            <a:off x="5623560" y="4160520"/>
+            <a:ext cx="914400" cy="914400"/>
+          </a:xfrm>
+          <a:prstGeom prst="rect">
+            <a:avLst/>
+          </a:prstGeom>
+          <a:noFill/>
+          <a:ln/>
+        </p:spPr>
+        <p:txBody>
+          <a:bodyPr wrap="square" lIns="0" tIns="0" rIns="0" bIns="0" rtlCol="0" anchor="ctr"/>
+          <a:lstStyle/>
+          <a:p>
+            <a:pPr marL="0" indent="0" algn="ctr">
+              <a:buNone/>
+            </a:pPr>
+            <a:r>
+              <a:rPr lang="en-US" sz="2800" b="1" dirty="0">
+                <a:solidFill>
+                  <a:srgbClr val="FFFFFF"/>
+                </a:solidFill>
+                <a:latin typeface="Calibri" pitchFamily="34" charset="0"/>
+                <a:ea typeface="Calibri" pitchFamily="34" charset="-122"/>
+                <a:cs typeface="Calibri" pitchFamily="34" charset="-120"/>
+              </a:rPr>
+              <a:t>P</a:t>
+            </a:r>
+            <a:endParaRPr lang="en-US" sz="2800" dirty="0"/>
+          </a:p>
+        </p:txBody>
+      </p:sp>
+      <p:sp>
+        <p:nvSpPr>
+          <p:cNvPr id="26" name="Text 24"/>
+          <p:cNvSpPr/>
+          <p:nvPr/>
+        </p:nvSpPr>
+        <p:spPr>
+          <a:xfrm>
+            <a:off x="4526280" y="5166360"/>
+            <a:ext cx="3154680" cy="365760"/>
+          </a:xfrm>
+          <a:prstGeom prst="rect">
+            <a:avLst/>
+          </a:prstGeom>
+          <a:noFill/>
+          <a:ln/>
+        </p:spPr>
+        <p:txBody>
+          <a:bodyPr wrap="square" lIns="0" tIns="0" rIns="0" bIns="0" rtlCol="0" anchor="ctr"/>
+          <a:lstStyle/>
+          <a:p>
+            <a:pPr marL="0" indent="0" algn="ctr">
+              <a:buNone/>
+            </a:pPr>
+            <a:r>
+              <a:rPr lang="en-US" sz="1600" b="1" dirty="0">
+                <a:solidFill>
+                  <a:srgbClr val="1B3A5C"/>
+                </a:solidFill>
+                <a:latin typeface="Calibri" pitchFamily="34" charset="0"/>
+                <a:ea typeface="Calibri" pitchFamily="34" charset="-122"/>
+                <a:cs typeface="Calibri" pitchFamily="34" charset="-120"/>
+              </a:rPr>
+              <a:t>python-dotenv</a:t>
+            </a:r>
+            <a:endParaRPr lang="en-US" sz="1600" dirty="0"/>
+          </a:p>
+        </p:txBody>
+      </p:sp>
+      <p:sp>
+        <p:nvSpPr>
+          <p:cNvPr id="27" name="Text 25"/>
+          <p:cNvSpPr/>
+          <p:nvPr/>
+        </p:nvSpPr>
+        <p:spPr>
+          <a:xfrm>
+            <a:off x="4526280" y="5486400"/>
+            <a:ext cx="3154680" cy="320040"/>
+          </a:xfrm>
+          <a:prstGeom prst="rect">
+            <a:avLst/>
+          </a:prstGeom>
+          <a:noFill/>
+          <a:ln/>
+        </p:spPr>
+        <p:txBody>
+          <a:bodyPr wrap="square" lIns="0" tIns="0" rIns="0" bIns="0" rtlCol="0" anchor="ctr"/>
+          <a:lstStyle/>
+          <a:p>
+            <a:pPr marL="0" indent="0" algn="ctr">
+              <a:buNone/>
+            </a:pPr>
+            <a:r>
+              <a:rPr lang="en-US" sz="1200" dirty="0">
+                <a:solidFill>
+                  <a:srgbClr val="6B7B8D"/>
+                </a:solidFill>
+                <a:latin typeface="Calibri" pitchFamily="34" charset="0"/>
+                <a:ea typeface="Calibri" pitchFamily="34" charset="-122"/>
+                <a:cs typeface="Calibri" pitchFamily="34" charset="-120"/>
+              </a:rPr>
+              <a:t>Secure credentials</a:t>
+            </a:r>
+            <a:endParaRPr lang="en-US" sz="1200" dirty="0"/>
+          </a:p>
+        </p:txBody>
+      </p:sp>
+      <p:sp>
+        <p:nvSpPr>
+          <p:cNvPr id="28" name="Shape 26"/>
+          <p:cNvSpPr/>
+          <p:nvPr/>
+        </p:nvSpPr>
+        <p:spPr>
+          <a:xfrm>
+            <a:off x="8138160" y="3931920"/>
+            <a:ext cx="3520440" cy="2011680"/>
+          </a:xfrm>
+          <a:prstGeom prst="roundRect">
+            <a:avLst>
+              <a:gd name="adj" fmla="val 4545"/>
+            </a:avLst>
+          </a:prstGeom>
+          <a:solidFill>
+            <a:srgbClr val="F4F6F9"/>
+          </a:solidFill>
+          <a:ln/>
+          <a:effectLst>
+            <a:outerShdw blurRad="38100" dist="12700" dir="8100000" algn="bl" rotWithShape="0">
+              <a:srgbClr val="CCCCCC">
+                <a:alpha val="30000"/>
+              </a:srgbClr>
+            </a:outerShdw>
+          </a:effectLst>
+        </p:spPr>
+      </p:sp>
+      <p:sp>
+        <p:nvSpPr>
+          <p:cNvPr id="29" name="Shape 27"/>
+          <p:cNvSpPr/>
+          <p:nvPr/>
+        </p:nvSpPr>
+        <p:spPr>
+          <a:xfrm>
+            <a:off x="9418320" y="4160520"/>
+            <a:ext cx="914400" cy="914400"/>
+          </a:xfrm>
+          <a:prstGeom prst="ellipse">
+            <a:avLst/>
+          </a:prstGeom>
+          <a:solidFill>
+            <a:srgbClr val="0F1B2D"/>
+          </a:solidFill>
+          <a:ln/>
+        </p:spPr>
+      </p:sp>
+      <p:sp>
+        <p:nvSpPr>
+          <p:cNvPr id="30" name="Text 28"/>
+          <p:cNvSpPr/>
+          <p:nvPr/>
+        </p:nvSpPr>
+        <p:spPr>
+          <a:xfrm>
+            <a:off x="9418320" y="4160520"/>
+            <a:ext cx="914400" cy="914400"/>
+          </a:xfrm>
+          <a:prstGeom prst="rect">
+            <a:avLst/>
+          </a:prstGeom>
+          <a:noFill/>
+          <a:ln/>
+        </p:spPr>
+        <p:txBody>
+          <a:bodyPr wrap="square" lIns="0" tIns="0" rIns="0" bIns="0" rtlCol="0" anchor="ctr"/>
+          <a:lstStyle/>
+          <a:p>
+            <a:pPr marL="0" indent="0" algn="ctr">
+              <a:buNone/>
+            </a:pPr>
+            <a:r>
+              <a:rPr lang="en-US" sz="2800" b="1" dirty="0">
+                <a:solidFill>
+                  <a:srgbClr val="FFFFFF"/>
+                </a:solidFill>
+                <a:latin typeface="Calibri" pitchFamily="34" charset="0"/>
+                <a:ea typeface="Calibri" pitchFamily="34" charset="-122"/>
+                <a:cs typeface="Calibri" pitchFamily="34" charset="-120"/>
+              </a:rPr>
+              <a:t>V</a:t>
+            </a:r>
+            <a:endParaRPr lang="en-US" sz="2800" dirty="0"/>
+          </a:p>
+        </p:txBody>
+      </p:sp>
+      <p:sp>
+        <p:nvSpPr>
+          <p:cNvPr id="31" name="Text 29"/>
+          <p:cNvSpPr/>
+          <p:nvPr/>
+        </p:nvSpPr>
+        <p:spPr>
+          <a:xfrm>
+            <a:off x="8321040" y="5166360"/>
+            <a:ext cx="3154680" cy="365760"/>
+          </a:xfrm>
+          <a:prstGeom prst="rect">
+            <a:avLst/>
+          </a:prstGeom>
+          <a:noFill/>
+          <a:ln/>
+        </p:spPr>
+        <p:txBody>
+          <a:bodyPr wrap="square" lIns="0" tIns="0" rIns="0" bIns="0" rtlCol="0" anchor="ctr"/>
+          <a:lstStyle/>
+          <a:p>
+            <a:pPr marL="0" indent="0" algn="ctr">
+              <a:buNone/>
+            </a:pPr>
+            <a:r>
+              <a:rPr lang="en-US" sz="1600" b="1" dirty="0">
+                <a:solidFill>
+                  <a:srgbClr val="1B3A5C"/>
+                </a:solidFill>
+                <a:latin typeface="Calibri" pitchFamily="34" charset="0"/>
+                <a:ea typeface="Calibri" pitchFamily="34" charset="-122"/>
+                <a:cs typeface="Calibri" pitchFamily="34" charset="-120"/>
+              </a:rPr>
+              <a:t>VS Code</a:t>
+            </a:r>
+            <a:endParaRPr lang="en-US" sz="1600" dirty="0"/>
+          </a:p>
+        </p:txBody>
+      </p:sp>
+      <p:sp>
+        <p:nvSpPr>
+          <p:cNvPr id="32" name="Text 30"/>
+          <p:cNvSpPr/>
+          <p:nvPr/>
+        </p:nvSpPr>
+        <p:spPr>
+          <a:xfrm>
+            <a:off x="8321040" y="5486400"/>
+            <a:ext cx="3154680" cy="320040"/>
+          </a:xfrm>
+          <a:prstGeom prst="rect">
+            <a:avLst/>
+          </a:prstGeom>
+          <a:noFill/>
+          <a:ln/>
+        </p:spPr>
+        <p:txBody>
+          <a:bodyPr wrap="square" lIns="0" tIns="0" rIns="0" bIns="0" rtlCol="0" anchor="ctr"/>
+          <a:lstStyle/>
+          <a:p>
+            <a:pPr marL="0" indent="0" algn="ctr">
+              <a:buNone/>
+            </a:pPr>
+            <a:r>
+              <a:rPr lang="en-US" sz="1200" dirty="0">
+                <a:solidFill>
+                  <a:srgbClr val="6B7B8D"/>
+                </a:solidFill>
+                <a:latin typeface="Calibri" pitchFamily="34" charset="0"/>
+                <a:ea typeface="Calibri" pitchFamily="34" charset="-122"/>
+                <a:cs typeface="Calibri" pitchFamily="34" charset="-120"/>
+              </a:rPr>
+              <a:t>Development environment</a:t>
+            </a:r>
+            <a:endParaRPr lang="en-US" sz="1200" dirty="0"/>
+          </a:p>
+        </p:txBody>
+      </p:sp>
+    </p:spTree>
+  </p:cSld>
+  <p:clrMapOvr>
+    <a:masterClrMapping/>
+  </p:clrMapOvr>
+</p:sld>
+</file>
+
+<file path=ppt/slides/slide8.xml><?xml version="1.0" encoding="utf-8"?>
 <p:sld xmlns:a="http://schemas.openxmlformats.org/drawingml/2006/main" xmlns:r="http://schemas.openxmlformats.org/officeDocument/2006/relationships" xmlns:p="http://schemas.openxmlformats.org/presentationml/2006/main">
   <p:cSld name="Slide 8">
     <p:bg>

</xml_diff>